<commit_message>
Update informe-final.typ: Revise entry costs and commercial pricing details for clarity
</commit_message>
<xml_diff>
--- a/TP_Especial_Zephyr_MOSIX_v2.pptx
+++ b/TP_Especial_Zephyr_MOSIX_v2.pptx
@@ -3655,7 +3655,7 @@
                 <a:ea typeface="Calibri" pitchFamily="34" charset="-122"/>
                 <a:cs typeface="Calibri" pitchFamily="34" charset="-120"/>
               </a:rPr>
-              <a:t>ARRIAGA  •  BELLONE  •  BISCAY  •  CALLA ALIENDE  •  CARDOZO</a:t>
+              <a:t>ARRIAGA • BELLONE • BISCAY • CALLA ALIENDE • CARDOZO</a:t>
             </a:r>
             <a:endParaRPr lang="en-US" sz="1100" dirty="0"/>
           </a:p>
@@ -5118,7 +5118,7 @@
                 <a:ea typeface="Calibri" pitchFamily="34" charset="-122"/>
                 <a:cs typeface="Calibri" pitchFamily="34" charset="-120"/>
               </a:rPr>
-              <a:t>Nota académica: MPU cómo alternativa a MMU (§4.4) — single address space elimina necesidad de paginación en la mayoría de configs (§5.1) — contraste con memoria virtual clásica</a:t>
+              <a:t/>
             </a:r>
             <a:endParaRPr lang="en-US" sz="900" dirty="0"/>
           </a:p>
@@ -6354,7 +6354,7 @@
                 <a:ea typeface="Calibri" pitchFamily="34" charset="-122"/>
                 <a:cs typeface="Calibri" pitchFamily="34" charset="-120"/>
               </a:rPr>
-              <a:t>Nota académica: Memory Ushering cómo distributed page replacement (§5.3) — checkpoint cómo serialización de estado (§2.3 PCB) — modelo shared-nothing contrasta con NUMA (§4.1)</a:t>
+              <a:t/>
             </a:r>
             <a:endParaRPr lang="en-US" sz="900" dirty="0"/>
           </a:p>
@@ -6610,7 +6610,7 @@
                 <a:ea typeface="Arial" pitchFamily="34" charset="-122"/>
                 <a:cs typeface="Arial" pitchFamily="34" charset="-120"/>
               </a:rPr>
-              <a:t>ESTADOS DE THREAD (§2.2)</a:t>
+              <a:t>ESTADOS DE THREAD </a:t>
             </a:r>
             <a:endParaRPr lang="en-US" sz="900" dirty="0"/>
           </a:p>
@@ -7001,7 +7001,7 @@
                 <a:ea typeface="Arial" pitchFamily="34" charset="-122"/>
                 <a:cs typeface="Arial" pitchFamily="34" charset="-120"/>
               </a:rPr>
-              <a:t>SIN QUANTUM CLÁSICO (§2.7, §2.8)</a:t>
+              <a:t>SIN QUANTUM CLÁSICO </a:t>
             </a:r>
             <a:endParaRPr lang="en-US" sz="900" dirty="0"/>
           </a:p>
@@ -7098,7 +7098,7 @@
                 <a:ea typeface="Calibri" pitchFamily="34" charset="-122"/>
                 <a:cs typeface="Calibri" pitchFamily="34" charset="-120"/>
               </a:rPr>
-              <a:t>Nota académica: k_thread cómo PCB simplificado (§2.3) — scheduling por prioridad vs Round Robin (§2.5) — single address space elimina context switch overhead (§2.8)</a:t>
+              <a:t/>
             </a:r>
             <a:endParaRPr lang="en-US" sz="900" dirty="0"/>
           </a:p>
@@ -7390,7 +7390,7 @@
                 <a:ea typeface="Arial" pitchFamily="34" charset="-122"/>
                 <a:cs typeface="Arial" pitchFamily="34" charset="-120"/>
               </a:rPr>
-              <a:t>MIGRACIÓN DE PROCESO (§2.3)</a:t>
+              <a:t>MIGRACIÓN DE PROCESO </a:t>
             </a:r>
             <a:endParaRPr lang="en-US" sz="900" dirty="0"/>
           </a:p>
@@ -8196,7 +8196,7 @@
                 <a:ea typeface="Arial" pitchFamily="34" charset="-122"/>
                 <a:cs typeface="Arial" pitchFamily="34" charset="-120"/>
               </a:rPr>
-              <a:t>LOAD BALANCING (§2.1, §2.4)</a:t>
+              <a:t>LOAD BALANCING </a:t>
             </a:r>
             <a:endParaRPr lang="en-US" sz="900" dirty="0"/>
           </a:p>
@@ -8483,7 +8483,7 @@
                 <a:ea typeface="Arial" pitchFamily="34" charset="-122"/>
                 <a:cs typeface="Arial" pitchFamily="34" charset="-120"/>
               </a:rPr>
-              <a:t>EFECTO CONVOY EVITADO (§2.6)</a:t>
+              <a:t>EFECTO CONVOY EVITADO </a:t>
             </a:r>
             <a:endParaRPr lang="en-US" sz="900" dirty="0"/>
           </a:p>
@@ -8561,7 +8561,7 @@
                 <a:ea typeface="Calibri" pitchFamily="34" charset="-122"/>
                 <a:cs typeface="Calibri" pitchFamily="34" charset="-120"/>
               </a:rPr>
-              <a:t>Nota académica: migración cómo scheduling de largo/mediano plazo (§2.4) — PCB serializado cómo checkpoint (§2.3) — convoy evitado por migración preemptiva (§2.6)</a:t>
+              <a:t/>
             </a:r>
             <a:endParaRPr lang="en-US" sz="900" dirty="0"/>
           </a:p>
@@ -8935,7 +8935,7 @@
                 <a:ea typeface="Arial" pitchFamily="34" charset="-122"/>
                 <a:cs typeface="Arial" pitchFamily="34" charset="-120"/>
               </a:rPr>
-              <a:t>MPU + MODO DUAL (§1.5, §1.6)</a:t>
+              <a:t>MPU + MODO DUAL </a:t>
             </a:r>
             <a:endParaRPr lang="en-US" sz="900" dirty="0"/>
           </a:p>
@@ -9097,7 +9097,7 @@
                 <a:ea typeface="Arial" pitchFamily="34" charset="-122"/>
                 <a:cs typeface="Arial" pitchFamily="34" charset="-120"/>
               </a:rPr>
-              <a:t>SINGLE ADDRESS SPACE + SYSCALLS (§1.7, §1.8)</a:t>
+              <a:t>SINGLE ADDRESS SPACE + SYSCALLS </a:t>
             </a:r>
             <a:endParaRPr lang="en-US" sz="900" dirty="0"/>
           </a:p>
@@ -9731,7 +9731,7 @@
                 <a:ea typeface="Calibri" pitchFamily="34" charset="-122"/>
                 <a:cs typeface="Calibri" pitchFamily="34" charset="-120"/>
               </a:rPr>
-              <a:t>Nota académica: MPU configurada con instrucciones privilegiadas (§1.6) — modo dual kernel/user enforced by hardware (§1.5) — syscalls como function calls sin mode switch (§1.7, §1.8)</a:t>
+              <a:t/>
             </a:r>
             <a:endParaRPr lang="en-US" sz="900" dirty="0"/>
           </a:p>
@@ -9987,7 +9987,7 @@
                 <a:ea typeface="Arial" pitchFamily="34" charset="-122"/>
                 <a:cs typeface="Arial" pitchFamily="34" charset="-120"/>
               </a:rPr>
-              <a:t>KERNEL MODULE EN MODO PRIVILEGIADO (§1.5, §1.6)</a:t>
+              <a:t>KERNEL MODULE EN MODO PRIVILEGIADO </a:t>
             </a:r>
             <a:endParaRPr lang="en-US" sz="900" dirty="0"/>
           </a:p>
@@ -10577,7 +10577,7 @@
                 <a:ea typeface="Calibri"/>
                 <a:cs typeface="Calibri"/>
               </a:rPr>
-              <a:t>⚠  REQUISITO CRÍTICO: Todos </a:t>
+              <a:t>⚠ REQUISITO CRÍTICO: Todos </a:t>
             </a:r>
             <a:r>
               <a:rPr lang="en-US" sz="1050" b="1" dirty="0" err="1">
@@ -10807,7 +10807,7 @@
                 <a:ea typeface="Calibri" pitchFamily="34" charset="-122"/>
                 <a:cs typeface="Calibri" pitchFamily="34" charset="-120"/>
               </a:rPr>
-              <a:t>Nota académica: sandbox a nivel kernel — filtro de syscalls análogo a seccomp (§1.7, §1.8) — confianza mutua vs. protección por hardware (§1.5, §1.6)</a:t>
+              <a:t/>
             </a:r>
             <a:endParaRPr lang="en-US" sz="900" dirty="0"/>
           </a:p>
@@ -11733,7 +11733,7 @@
                 <a:ea typeface="Calibri" pitchFamily="34" charset="-122"/>
                 <a:cs typeface="Calibri" pitchFamily="34" charset="-120"/>
               </a:rPr>
-              <a:t>open(), close(), read(), write(), socket()</a:t>
+              <a:t>open, close, read, write, socket</a:t>
             </a:r>
             <a:endParaRPr lang="en-US" sz="900" dirty="0"/>
           </a:p>
@@ -11952,7 +11952,7 @@
                 <a:ea typeface="Calibri" pitchFamily="34" charset="-122"/>
                 <a:cs typeface="Calibri" pitchFamily="34" charset="-120"/>
               </a:rPr>
-              <a:t>Nota académica §1.8: API POSIX cómo interfaz stable entre aplicación y kernel — syscalls (open, close, read, write, socket) son el mecanismo clásico de transición usuario→kernel</a:t>
+              <a:t/>
             </a:r>
             <a:endParaRPr lang="en-US" sz="900" dirty="0"/>
           </a:p>
@@ -12266,7 +12266,7 @@
                 <a:ea typeface="Calibri" pitchFamily="34" charset="-122"/>
                 <a:cs typeface="Calibri" pitchFamily="34" charset="-120"/>
               </a:rPr>
-              <a:t>Syscalls estándar: fork(), exec(), read(), write()</a:t>
+              <a:t>Syscalls estándar: fork, exec, read, write</a:t>
             </a:r>
             <a:endParaRPr lang="en-US" sz="900" dirty="0"/>
           </a:p>
@@ -13097,7 +13097,7 @@
                 <a:ea typeface="Calibri" pitchFamily="34" charset="-122"/>
                 <a:cs typeface="Calibri" pitchFamily="34" charset="-120"/>
               </a:rPr>
-              <a:t>Nota académica §1.8: MOSIX extiende el kernel sin cambiar la interfaz de syscalls — ABI POSIX estable permite transparencia — /proc/hpc cómo procfs dinámico (§1.7)</a:t>
+              <a:t/>
             </a:r>
             <a:endParaRPr lang="en-US" sz="900" dirty="0"/>
           </a:p>
@@ -14414,7 +14414,7 @@
                 <a:ea typeface="Calibri" pitchFamily="34" charset="-122"/>
                 <a:cs typeface="Calibri" pitchFamily="34" charset="-120"/>
               </a:rPr>
-              <a:t>Nota académica: §1.4 (arquitecturas — single address space), §2.5 (scheduling — multi-level feedback queue), §3.6 (filesystem — LittleFS)</a:t>
+              <a:t/>
             </a:r>
             <a:endParaRPr lang="en-US" sz="900" dirty="0"/>
           </a:p>
@@ -15561,7 +15561,7 @@
                 <a:ea typeface="Calibri" pitchFamily="34" charset="-122"/>
                 <a:cs typeface="Calibri" pitchFamily="34" charset="-120"/>
               </a:rPr>
-              <a:t>Nota académica: §1.4 (arquitecturas — SO distribuido), §2.5 (scheduling — balanceo de carga distribuido)</a:t>
+              <a:t/>
             </a:r>
             <a:endParaRPr lang="en-US" sz="900" dirty="0"/>
           </a:p>
@@ -19464,7 +19464,7 @@
                 <a:ea typeface="Calibri" pitchFamily="34" charset="-122"/>
                 <a:cs typeface="Calibri" pitchFamily="34" charset="-120"/>
               </a:rPr>
-              <a:t>Nota académica: §1.2 (gen 5ª) — Zephyr ejemplifica la era de IoT y edge computing con 1,000+ boards soportadas y adoptacion creciente en productos comerciales de largo ciclo de vida</a:t>
+              <a:t/>
             </a:r>
             <a:endParaRPr lang="en-US" sz="900" dirty="0"/>
           </a:p>
@@ -21052,7 +21052,7 @@
                 <a:ea typeface="Calibri" pitchFamily="34" charset="-122"/>
                 <a:cs typeface="Calibri" pitchFamily="34" charset="-120"/>
               </a:rPr>
-              <a:t>Nota académica: §1.2 (gen 4ª) — MOSIX cómo caso de estudio de transición entre eras (clusters PC → cloud-native) — obsoleto técnicamente pero ilustra evolución de arquitecturas distribuidas</a:t>
+              <a:t/>
             </a:r>
             <a:endParaRPr lang="en-US" sz="900" dirty="0"/>
           </a:p>
@@ -22511,7 +22511,7 @@
                 <a:ea typeface="Calibri" pitchFamily="34" charset="-122"/>
                 <a:cs typeface="Calibri" pitchFamily="34" charset="-120"/>
               </a:rPr>
-              <a:t>Nota académica: §1.1 (gestión de recursos — ecosistema de soporte), §1.2 (comunidad como diferenciador en 5ª generación)</a:t>
+              <a:t/>
             </a:r>
             <a:endParaRPr lang="en-US" sz="900" dirty="0"/>
           </a:p>
@@ -23859,7 +23859,7 @@
                 <a:ea typeface="Calibri" pitchFamily="34" charset="-122"/>
                 <a:cs typeface="Calibri" pitchFamily="34" charset="-120"/>
               </a:rPr>
-              <a:t>Nota académica: §1.1 (documentación como recurso — sin mantenimiento un SO se vuelve inútil), §1.4 (licencia y ciclo de vida)</a:t>
+              <a:t/>
             </a:r>
             <a:endParaRPr lang="en-US" sz="800" dirty="0"/>
           </a:p>
@@ -25598,7 +25598,7 @@
                 <a:ea typeface="Calibri" pitchFamily="34" charset="-122"/>
                 <a:cs typeface="Calibri" pitchFamily="34" charset="-120"/>
               </a:rPr>
-              <a:t>Nota académica: §1.1 (máquina extendida, gestor de recursos), §2.1 (multiprogramación embebida)</a:t>
+              <a:t/>
             </a:r>
             <a:endParaRPr lang="en-US" sz="900" dirty="0"/>
           </a:p>
@@ -27202,7 +27202,7 @@
                 <a:ea typeface="Calibri" pitchFamily="34" charset="-122"/>
                 <a:cs typeface="Calibri" pitchFamily="34" charset="-120"/>
               </a:rPr>
-              <a:t>Nota académica: §1.1 (gestor de recursos — cluster como máquina única), §4.1 (administración de memoria distribuida — Memory Ushering)</a:t>
+              <a:t/>
             </a:r>
             <a:endParaRPr lang="en-US" sz="900" dirty="0"/>
           </a:p>
@@ -28333,7 +28333,7 @@
                 <a:ea typeface="Calibri" pitchFamily="34" charset="-122"/>
                 <a:cs typeface="Calibri" pitchFamily="34" charset="-120"/>
               </a:rPr>
-              <a:t>Nota académica: Modelo de distribución — software libre vs propietario (§1.1)</a:t>
+              <a:t/>
             </a:r>
             <a:endParaRPr lang="en-US" sz="900" dirty="0"/>
           </a:p>
@@ -28939,7 +28939,7 @@
                 <a:ea typeface="Arial" pitchFamily="34" charset="-122"/>
                 <a:cs typeface="Arial" pitchFamily="34" charset="-120"/>
               </a:rPr>
-              <a:t>PRECIO HISTÓRICO (2000)</a:t>
+              <a:t>CONTEXTO DE PRICING</a:t>
             </a:r>
             <a:endParaRPr lang="en-US" sz="1100" dirty="0"/>
           </a:p>
@@ -29003,7 +29003,7 @@
                 <a:ea typeface="Calibri" pitchFamily="34" charset="-122"/>
                 <a:cs typeface="Calibri" pitchFamily="34" charset="-120"/>
               </a:rPr>
-              <a:t>OBSOLETO — NO VÁLIDO</a:t>
+              <a:t>MOSIX era gratuito para uso académico (sin costo de licencia)</a:t>
             </a:r>
             <a:endParaRPr lang="en-US" sz="900" dirty="0"/>
           </a:p>
@@ -29042,7 +29042,7 @@
                 <a:ea typeface="Calibri" pitchFamily="34" charset="-122"/>
                 <a:cs typeface="Calibri" pitchFamily="34" charset="-120"/>
               </a:rPr>
-              <a:t>~USD $61,141 upfront + $16,835/year</a:t>
+              <a:t>Precio comercial post-2001: Sin documentación pública</a:t>
             </a:r>
             <a:endParaRPr lang="en-US" sz="1000" dirty="0"/>
           </a:p>
@@ -29081,7 +29081,7 @@
                 <a:ea typeface="Calibri" pitchFamily="34" charset="-122"/>
                 <a:cs typeface="Calibri" pitchFamily="34" charset="-120"/>
               </a:rPr>
-              <a:t>Fuente: USENIX 2000</a:t>
+              <a:t/>
             </a:r>
             <a:endParaRPr lang="en-US" sz="800" dirty="0"/>
           </a:p>
@@ -29120,7 +29120,7 @@
                 <a:ea typeface="Calibri" pitchFamily="34" charset="-122"/>
                 <a:cs typeface="Calibri" pitchFamily="34" charset="-120"/>
               </a:rPr>
-              <a:t>Precio actual:</a:t>
+              <a:t/>
             </a:r>
             <a:endParaRPr lang="en-US" sz="1000" dirty="0"/>
           </a:p>
@@ -29159,7 +29159,7 @@
                 <a:ea typeface="Calibri" pitchFamily="34" charset="-122"/>
                 <a:cs typeface="Calibri" pitchFamily="34" charset="-120"/>
               </a:rPr>
-              <a:t>❌ NO DISPONIBLE PÚBLICAMENTE</a:t>
+              <a:t/>
             </a:r>
             <a:endParaRPr lang="en-US" sz="900" dirty="0"/>
           </a:p>
@@ -29198,7 +29198,7 @@
                 <a:ea typeface="Calibri" pitchFamily="34" charset="-122"/>
                 <a:cs typeface="Calibri" pitchFamily="34" charset="-120"/>
               </a:rPr>
-              <a:t>Contacto: mosix@cs.huji.ac.il</a:t>
+              <a:t/>
             </a:r>
             <a:endParaRPr lang="en-US" sz="800" dirty="0"/>
           </a:p>
@@ -29301,7 +29301,7 @@
                 <a:ea typeface="Calibri" pitchFamily="34" charset="-122"/>
                 <a:cs typeface="Calibri" pitchFamily="34" charset="-120"/>
               </a:rPr>
-              <a:t>Nota académica: Modelos de licenciamiento — propietario vs open source (§1.1)</a:t>
+              <a:t/>
             </a:r>
             <a:endParaRPr lang="en-US" sz="900" dirty="0"/>
           </a:p>
@@ -31247,7 +31247,7 @@
                 <a:ea typeface="Calibri" pitchFamily="34" charset="-122"/>
                 <a:cs typeface="Calibri" pitchFamily="34" charset="-120"/>
               </a:rPr>
-              <a:t>Nota académica: todas las secciones — §1.4 (arquitectura), §2.5 (scheduling), §4.4/5.3 (memoria), §3.6 (filesystem)</a:t>
+              <a:t/>
             </a:r>
             <a:endParaRPr lang="en-US" sz="900" dirty="0"/>
           </a:p>
@@ -31957,7 +31957,7 @@
                 <a:ea typeface="Calibri" pitchFamily="34" charset="-122"/>
                 <a:cs typeface="Calibri" pitchFamily="34" charset="-120"/>
               </a:rPr>
-              <a:t>§1.4 — arquitectura correcta para problema</a:t>
+              <a:t/>
             </a:r>
             <a:endParaRPr lang="en-US" sz="800" dirty="0"/>
           </a:p>
@@ -32394,7 +32394,7 @@
                 <a:ea typeface="Calibri" pitchFamily="34" charset="-122"/>
                 <a:cs typeface="Calibri" pitchFamily="34" charset="-120"/>
               </a:rPr>
-              <a:t>Nota académica: §1.4 (diseño de SO depende del dominio), §2.5 (scheduling domains), evolución clusters → contenedores</a:t>
+              <a:t/>
             </a:r>
             <a:endParaRPr lang="en-US" sz="900" dirty="0"/>
           </a:p>
@@ -33522,7 +33522,7 @@
                 <a:ea typeface="Calibri" pitchFamily="34" charset="-122"/>
                 <a:cs typeface="Calibri" pitchFamily="34" charset="-120"/>
               </a:rPr>
-              <a:t>Nota académica: Zephyr ejemplifica evolución de SO desde sistemas propietarios (VxWorks) hacia open source — modelo Linux Foundation §1.2, §1.4</a:t>
+              <a:t/>
             </a:r>
             <a:endParaRPr lang="en-US" sz="900" dirty="0"/>
           </a:p>
@@ -36358,7 +36358,7 @@
                 <a:ea typeface="Calibri" pitchFamily="34" charset="-122"/>
                 <a:cs typeface="Calibri" pitchFamily="34" charset="-120"/>
               </a:rPr>
-              <a:t>Nota académica: Zephyr cómo 'máquina extendida' (§1.1) — abstrae hardware heterogéneo de MCUs, ocultando complejidad al desarrollador</a:t>
+              <a:t/>
             </a:r>
             <a:endParaRPr lang="en-US" sz="900" dirty="0"/>
           </a:p>
@@ -37771,7 +37771,7 @@
                 <a:ea typeface="Calibri" pitchFamily="34" charset="-122"/>
                 <a:cs typeface="Calibri" pitchFamily="34" charset="-120"/>
               </a:rPr>
-              <a:t>Nota académica: MOSIX como caso de evolución de arquitecturas distribuidas (§1.2, §1.4) — SSI como 'máquina extendida' a nivel cluster</a:t>
+              <a:t/>
             </a:r>
             <a:endParaRPr lang="en-US" sz="900" dirty="0"/>
           </a:p>
@@ -39278,7 +39278,7 @@
                 <a:ea typeface="Calibri" pitchFamily="34" charset="-122"/>
                 <a:cs typeface="Calibri" pitchFamily="34" charset="-120"/>
               </a:rPr>
-              <a:t>1,000+ boards  •  &gt;15 arquitecturas  •  ~4 KB footprint mínimo</a:t>
+              <a:t>1,000+ boards • &gt;15 arquitecturas • ~4 KB footprint mínimo</a:t>
             </a:r>
             <a:endParaRPr lang="en-US" sz="1000" dirty="0"/>
           </a:p>
@@ -39317,7 +39317,7 @@
                 <a:ea typeface="Calibri" pitchFamily="34" charset="-122"/>
                 <a:cs typeface="Calibri" pitchFamily="34" charset="-120"/>
               </a:rPr>
-              <a:t>Nota académica: Zephyr como microkernel-like monolith — single address space elimina context switch (§1.4, §1.5) — contraste con Unix/Linux kernel tradicional</a:t>
+              <a:t/>
             </a:r>
             <a:endParaRPr lang="en-US" sz="900" dirty="0"/>
           </a:p>
@@ -40573,7 +40573,7 @@
                 <a:ea typeface="Calibri" pitchFamily="34" charset="-122"/>
                 <a:cs typeface="Calibri" pitchFamily="34" charset="-120"/>
               </a:rPr>
-              <a:t>Nota académica: MOSIX cómo Distributed OS (§1.4) — SSI cómo 'máquina extendida' a nivel cluster, migración de procesos como scheduling distribuido (§2.1, §2.4)</a:t>
+              <a:t/>
             </a:r>
             <a:endParaRPr lang="en-US" sz="900" dirty="0"/>
           </a:p>
@@ -41777,7 +41777,7 @@
                 <a:ea typeface="Arial" pitchFamily="34" charset="-122"/>
                 <a:cs typeface="Arial" pitchFamily="34" charset="-120"/>
               </a:rPr>
-              <a:t>COMPARACIÓN CON UNIX (§3.8, §3.9)</a:t>
+              <a:t>COMPARACIÓN CON UNIX </a:t>
             </a:r>
             <a:endParaRPr lang="en-US" sz="900" dirty="0"/>
           </a:p>
@@ -41816,7 +41816,7 @@
                 <a:ea typeface="Calibri" pitchFamily="34" charset="-122"/>
                 <a:cs typeface="Calibri" pitchFamily="34" charset="-120"/>
               </a:rPr>
-              <a:t>✗ Sin i-nodos   ✗ Sin symbolic links   ✗ Sin permisos rwx (no hay owner/group)   ✗ NVS sin nombres de archivo</a:t>
+              <a:t>✗ Sin i-nodos ✗ Sin symbolic links ✗ Sin permisos rwx (no hay owner/group) ✗ NVS sin nombres de archivo</a:t>
             </a:r>
             <a:endParaRPr lang="en-US" sz="900" dirty="0"/>
           </a:p>
@@ -41855,7 +41855,7 @@
                 <a:ea typeface="Calibri" pitchFamily="34" charset="-122"/>
                 <a:cs typeface="Calibri" pitchFamily="34" charset="-120"/>
               </a:rPr>
-              <a:t>Nota académica: VFS cómo abstracción de FS en sentido amplio (§3.1) — FAT cómo método de asignación (§3.6) — modelo más cercano a DOS que UNIX (§3.9)</a:t>
+              <a:t/>
             </a:r>
             <a:endParaRPr lang="en-US" sz="900" dirty="0"/>
           </a:p>
@@ -43941,7 +43941,7 @@
                 <a:ea typeface="Calibri" pitchFamily="34" charset="-122"/>
                 <a:cs typeface="Calibri" pitchFamily="34" charset="-120"/>
               </a:rPr>
-              <a:t>Nota académica: DFSA cómo capa de interposición sobre syscalls (§3.1) — ausencia de parallel FS contrasta con sistemas de archivos distribuidos modernos (§3.6)</a:t>
+              <a:t/>
             </a:r>
             <a:endParaRPr lang="en-US" sz="900" dirty="0"/>
           </a:p>

</xml_diff>